<commit_message>
Add guided instructional strategies to Week 1 lesson slides
</commit_message>
<xml_diff>
--- a/dist/slides/u1-w01-l01.pptx
+++ b/dist/slides/u1-w01-l01.pptx
@@ -2,20 +2,20 @@
 <file path=ppt/presentation.xml><?xml version="1.0" encoding="utf-8"?>
 <p:presentation xmlns:p="http://schemas.openxmlformats.org/presentationml/2006/main">
   <p:sldMasterIdLst>
-    <p:sldMasterId xmlns:r="http://schemas.openxmlformats.org/officeDocument/2006/relationships" id="2147483648" r:id="R945132b746be4987"/>
+    <p:sldMasterId xmlns:r="http://schemas.openxmlformats.org/officeDocument/2006/relationships" id="2147483648" r:id="R694233200cd34e9a"/>
   </p:sldMasterIdLst>
   <p:notesMasterIdLst>
-    <p:notesMasterId xmlns:r="http://schemas.openxmlformats.org/officeDocument/2006/relationships" r:id="Rabca02e5e588448d"/>
+    <p:notesMasterId xmlns:r="http://schemas.openxmlformats.org/officeDocument/2006/relationships" r:id="Ra7210c8a3d4e4d03"/>
   </p:notesMasterIdLst>
   <p:sldIdLst>
-    <p:sldId xmlns:r="http://schemas.openxmlformats.org/officeDocument/2006/relationships" id="256" r:id="Rdca2fceee1aa41bb"/>
-    <p:sldId xmlns:r="http://schemas.openxmlformats.org/officeDocument/2006/relationships" id="257" r:id="Rca55cb43cb7b46dc"/>
-    <p:sldId xmlns:r="http://schemas.openxmlformats.org/officeDocument/2006/relationships" id="258" r:id="R42884f71ca364f33"/>
-    <p:sldId xmlns:r="http://schemas.openxmlformats.org/officeDocument/2006/relationships" id="259" r:id="R8435b703b1e8483b"/>
-    <p:sldId xmlns:r="http://schemas.openxmlformats.org/officeDocument/2006/relationships" id="260" r:id="R4dcb7c7013a54fcb"/>
-    <p:sldId xmlns:r="http://schemas.openxmlformats.org/officeDocument/2006/relationships" id="261" r:id="Ra086ff35e07d40be"/>
-    <p:sldId xmlns:r="http://schemas.openxmlformats.org/officeDocument/2006/relationships" id="262" r:id="R83575b0965a7422c"/>
-    <p:sldId xmlns:r="http://schemas.openxmlformats.org/officeDocument/2006/relationships" id="263" r:id="R147f43f954c1413b"/>
+    <p:sldId xmlns:r="http://schemas.openxmlformats.org/officeDocument/2006/relationships" id="256" r:id="R0dddf5c2334c46bf"/>
+    <p:sldId xmlns:r="http://schemas.openxmlformats.org/officeDocument/2006/relationships" id="257" r:id="R5e3b4dda7e964ef8"/>
+    <p:sldId xmlns:r="http://schemas.openxmlformats.org/officeDocument/2006/relationships" id="258" r:id="Rc780bf6ace164aa5"/>
+    <p:sldId xmlns:r="http://schemas.openxmlformats.org/officeDocument/2006/relationships" id="259" r:id="Ra52feae1558944f8"/>
+    <p:sldId xmlns:r="http://schemas.openxmlformats.org/officeDocument/2006/relationships" id="260" r:id="R816d7b5d86874a89"/>
+    <p:sldId xmlns:r="http://schemas.openxmlformats.org/officeDocument/2006/relationships" id="261" r:id="R0110998790494a83"/>
+    <p:sldId xmlns:r="http://schemas.openxmlformats.org/officeDocument/2006/relationships" id="262" r:id="R73926c48268d4ec7"/>
+    <p:sldId xmlns:r="http://schemas.openxmlformats.org/officeDocument/2006/relationships" id="263" r:id="R0a3622130d554571"/>
   </p:sldIdLst>
   <p:sldSz cx="12192000" cy="6858000"/>
   <p:notesSz cx="6858000" cy="9144000"/>
@@ -454,7 +454,12 @@
           </a:p>
           <a:p xmlns:a="http://schemas.openxmlformats.org/drawingml/2006/main">
             <a:r>
-              <a:t>Introduce the week: plan, run, trace/test, then apply. This lesson is diagnostic and formative.</a:t>
+              <a:t>Instructional strategy: Learning intention.</a:t>
+            </a:r>
+          </a:p>
+          <a:p xmlns:a="http://schemas.openxmlformats.org/drawingml/2006/main">
+            <a:r>
+              <a:t>Introduce the week: plan, run, trace/test, then apply. Ask learners to explain what a successful badge calculator would do. This lesson is diagnostic and formative.</a:t>
             </a:r>
           </a:p>
           <a:p xmlns:a="http://schemas.openxmlformats.org/drawingml/2006/main">
@@ -554,7 +559,12 @@
           </a:p>
           <a:p xmlns:a="http://schemas.openxmlformats.org/drawingml/2006/main">
             <a:r>
-              <a:t>Think-pair-share. Expected: quantity is needed; multiply four by three to obtain $12. Ask how the same method works for a different quantity. Do not assume prior coding experience.</a:t>
+              <a:t>Instructional strategy: Think, pair, share.</a:t>
+            </a:r>
+          </a:p>
+          <a:p xmlns:a="http://schemas.openxmlformats.org/drawingml/2006/main">
+            <a:r>
+              <a:t>Allow 45 seconds of silent thinking, one minute comparing, then invite two explanations. Expected: quantity is input, 4 × 3 = $12, 6 × 3 = $18. Accept diagrams or spoken explanations. If learners add 3 to the quantity, use equal groups to model the price per badge.</a:t>
             </a:r>
           </a:p>
           <a:p xmlns:a="http://schemas.openxmlformats.org/drawingml/2006/main">
@@ -654,7 +664,12 @@
           </a:p>
           <a:p xmlns:a="http://schemas.openxmlformats.org/drawingml/2006/main">
             <a:r>
-              <a:t>Success criteria: identify quantity as input, multiplication as processing and displayed total as output; give a correct expected result for a new quantity. Distinguish a variable quantity from the stated fixed price.</a:t>
+              <a:t>Instructional strategy: Success criteria.</a:t>
+            </a:r>
+          </a:p>
+          <a:p xmlns:a="http://schemas.openxmlformats.org/drawingml/2006/main">
+            <a:r>
+              <a:t>Have learners restate one criterion in their own words. Distinguish the variable quantity from the stated fixed price. Return to these criteria at the exit check.</a:t>
             </a:r>
           </a:p>
           <a:p xmlns:a="http://schemas.openxmlformats.org/drawingml/2006/main">
@@ -754,7 +769,12 @@
           </a:p>
           <a:p xmlns:a="http://schemas.openxmlformats.org/drawingml/2006/main">
             <a:r>
-              <a:t>Ask what valid means here. Zero is allowed. Negative quantities, words and decimal text are outside this introductory assumption; do not claim this is a finished robust application.</a:t>
+              <a:t>Instructional strategy: Teacher modelling.</a:t>
+            </a:r>
+          </a:p>
+          <a:p xmlns:a="http://schemas.openxmlformats.org/drawingml/2006/main">
+            <a:r>
+              <a:t>Think aloud as you underline quantity, circle the price and identify the required output. Model why zero is allowed by the stated requirement. Ask everyone to identify one valid input before continuing. If several learners choose a negative quantity, revisit the assumption. Validation comes later.</a:t>
             </a:r>
           </a:p>
           <a:p xmlns:a="http://schemas.openxmlformats.org/drawingml/2006/main">
@@ -854,7 +874,12 @@
           </a:p>
           <a:p xmlns:a="http://schemas.openxmlformats.org/drawingml/2006/main">
             <a:r>
-              <a:t>Model one row at a time verbally. Learners then annotate the same stages for quantity 6. Expected total: $18. The number read is not the displayed answer.</a:t>
+              <a:t>Instructional strategy: Worked example and guided practice.</a:t>
+            </a:r>
+          </a:p>
+          <a:p xmlns:a="http://schemas.openxmlformats.org/drawingml/2006/main">
+            <a:r>
+              <a:t>Model input 4, processing 4 × 3 and output Total: $12, explaining each decision. Then learners create the same three rows for quantity 6 without copying the numbers. Ask everyone to show their processing row. Expected $18. If they write 6 + 3, model equal groups again before independent practice.</a:t>
             </a:r>
           </a:p>
           <a:p xmlns:a="http://schemas.openxmlformats.org/drawingml/2006/main">
@@ -954,7 +979,12 @@
           </a:p>
           <a:p xmlns:a="http://schemas.openxmlformats.org/drawingml/2006/main">
             <a:r>
-              <a:t>Independent paper task, then compare reasoning. Expected totals: $0, $3 and $18. An algorithm is an ordered method; Python will be one way to implement it. Ask why displaying the result before calculating it would fail.</a:t>
+              <a:t>Instructional strategy: Independent practice and peer explanation.</a:t>
+            </a:r>
+          </a:p>
+          <a:p xmlns:a="http://schemas.openxmlformats.org/drawingml/2006/main">
+            <a:r>
+              <a:t>Allow six minutes independently, three minutes of explanation in pairs, then three minutes to revise. Expected sequence: read quantity, multiply by 3, display total. Expected totals $0, $3, $18. Support: offer the three stage names Input, Processing, Output. Stretch: explain why displaying total before assigning it fails. Keep individual plans as evidence.</a:t>
             </a:r>
           </a:p>
           <a:p xmlns:a="http://schemas.openxmlformats.org/drawingml/2006/main">
@@ -1054,7 +1084,12 @@
           </a:p>
           <a:p xmlns:a="http://schemas.openxmlformats.org/drawingml/2006/main">
             <a:r>
-              <a:t>Use a deliberately incorrect rule, quantity + 3, for six badges: it produces 9 rather than 18. A plan that produces output can still be wrong. Keep corrected input/process/output notes as evidence.</a:t>
+              <a:t>Instructional strategy: All-student misconception check.</a:t>
+            </a:r>
+          </a:p>
+          <a:p xmlns:a="http://schemas.openxmlformats.org/drawingml/2006/main">
+            <a:r>
+              <a:t>Collect a simultaneous response before discussion so every learner commits. Correct B gives $18. A gives $9 and adds a price once rather than charging for each badge. If several choose A, use a drawing of six groups of $3 and ask a fresh check for two badges before moving on.</a:t>
             </a:r>
           </a:p>
           <a:p xmlns:a="http://schemas.openxmlformats.org/drawingml/2006/main">
@@ -1154,7 +1189,12 @@
           </a:p>
           <a:p xmlns:a="http://schemas.openxmlformats.org/drawingml/2006/main">
             <a:r>
-              <a:t>Expected: quantity 7; multiply by 3; Total: $21. Expected results provide an independent correctness check. Reteach any confusion between reading input and processing before the next lesson.</a:t>
+              <a:t>Instructional strategy: Independent exit ticket.</a:t>
+            </a:r>
+          </a:p>
+          <a:p xmlns:a="http://schemas.openxmlformats.org/drawingml/2006/main">
+            <a:r>
+              <a:t>Collect an individual written response without partner help. Expected input quantity 7, processing multiply by 3, Total: $21. An independent expectation checks correctness. Sort responses into ready, input/processing confusion and calculation support, and use these groups to plan the next lesson starter.</a:t>
             </a:r>
           </a:p>
           <a:p xmlns:a="http://schemas.openxmlformats.org/drawingml/2006/main">
@@ -1226,7 +1266,7 @@
           <p:cNvPr id="3" name="Title">
             <a:extLst xmlns:a="http://schemas.openxmlformats.org/drawingml/2006/main">
               <a:ext uri="{FF2B5EF4-FFF2-40B4-BE49-F238E27FC236}">
-                <a16:creationId xmlns:a16="http://schemas.microsoft.com/office/drawing/2014/main" id="{690170F4-7DE9-4BB4-AA2E-DB7F92449B2F}"/>
+                <a16:creationId xmlns:a16="http://schemas.microsoft.com/office/drawing/2014/main" id="{F130A1A3-1FFA-4DF6-9708-46055FE5F57A}"/>
               </a:ext>
             </a:extLst>
           </p:cNvPr>
@@ -1383,7 +1423,7 @@
           <p:cNvPr id="2" name="Subtitle">
             <a:extLst xmlns:a="http://schemas.openxmlformats.org/drawingml/2006/main">
               <a:ext uri="{FF2B5EF4-FFF2-40B4-BE49-F238E27FC236}">
-                <a16:creationId xmlns:a16="http://schemas.microsoft.com/office/drawing/2014/main" id="{AF5F368B-5EA1-4F81-AC16-641B13840AF4}"/>
+                <a16:creationId xmlns:a16="http://schemas.microsoft.com/office/drawing/2014/main" id="{C8A36D88-F10D-45BE-8F18-3A55CE53E508}"/>
               </a:ext>
             </a:extLst>
           </p:cNvPr>
@@ -1557,7 +1597,7 @@
           <p:cNvPr id="2" name="Section title">
             <a:extLst xmlns:a="http://schemas.openxmlformats.org/drawingml/2006/main">
               <a:ext uri="{FF2B5EF4-FFF2-40B4-BE49-F238E27FC236}">
-                <a16:creationId xmlns:a16="http://schemas.microsoft.com/office/drawing/2014/main" id="{BD32477C-31ED-4041-B2B3-5CFC60982DBE}"/>
+                <a16:creationId xmlns:a16="http://schemas.microsoft.com/office/drawing/2014/main" id="{8899A956-0F30-49A9-84DA-46C8C4A50980}"/>
               </a:ext>
             </a:extLst>
           </p:cNvPr>
@@ -1731,7 +1771,7 @@
           <p:cNvPr id="3" name="Title">
             <a:extLst xmlns:a="http://schemas.openxmlformats.org/drawingml/2006/main">
               <a:ext uri="{FF2B5EF4-FFF2-40B4-BE49-F238E27FC236}">
-                <a16:creationId xmlns:a16="http://schemas.microsoft.com/office/drawing/2014/main" id="{9B85A749-F7F4-4CFD-A1AD-C3F339A415E7}"/>
+                <a16:creationId xmlns:a16="http://schemas.microsoft.com/office/drawing/2014/main" id="{DDA08D6F-F229-4870-BA47-4CD38FC0E54D}"/>
               </a:ext>
             </a:extLst>
           </p:cNvPr>
@@ -1888,7 +1928,7 @@
           <p:cNvPr id="2" name="Body">
             <a:extLst xmlns:a="http://schemas.openxmlformats.org/drawingml/2006/main">
               <a:ext uri="{FF2B5EF4-FFF2-40B4-BE49-F238E27FC236}">
-                <a16:creationId xmlns:a16="http://schemas.microsoft.com/office/drawing/2014/main" id="{AC99A13C-A840-4041-9A24-CE22B6B611D3}"/>
+                <a16:creationId xmlns:a16="http://schemas.microsoft.com/office/drawing/2014/main" id="{83854143-11A7-42DE-8C68-E466339ADABF}"/>
               </a:ext>
             </a:extLst>
           </p:cNvPr>
@@ -2062,7 +2102,7 @@
           <p:cNvPr id="4" name="Title">
             <a:extLst xmlns:a="http://schemas.openxmlformats.org/drawingml/2006/main">
               <a:ext uri="{FF2B5EF4-FFF2-40B4-BE49-F238E27FC236}">
-                <a16:creationId xmlns:a16="http://schemas.microsoft.com/office/drawing/2014/main" id="{65ADF4E3-6254-471D-8C95-A70A91E55940}"/>
+                <a16:creationId xmlns:a16="http://schemas.microsoft.com/office/drawing/2014/main" id="{4E229A4D-ABE2-4466-A902-130BA0C7E658}"/>
               </a:ext>
             </a:extLst>
           </p:cNvPr>
@@ -2219,7 +2259,7 @@
           <p:cNvPr id="2" name="Left column">
             <a:extLst xmlns:a="http://schemas.openxmlformats.org/drawingml/2006/main">
               <a:ext uri="{FF2B5EF4-FFF2-40B4-BE49-F238E27FC236}">
-                <a16:creationId xmlns:a16="http://schemas.microsoft.com/office/drawing/2014/main" id="{7979750F-D56D-4FC6-A7D0-27D44C92C12D}"/>
+                <a16:creationId xmlns:a16="http://schemas.microsoft.com/office/drawing/2014/main" id="{6AA36214-A3DC-4756-9BC9-65EC801AC46F}"/>
               </a:ext>
             </a:extLst>
           </p:cNvPr>
@@ -2376,7 +2416,7 @@
           <p:cNvPr id="3" name="Right column">
             <a:extLst xmlns:a="http://schemas.openxmlformats.org/drawingml/2006/main">
               <a:ext uri="{FF2B5EF4-FFF2-40B4-BE49-F238E27FC236}">
-                <a16:creationId xmlns:a16="http://schemas.microsoft.com/office/drawing/2014/main" id="{386C6F99-100F-44E9-B8EA-985E99E907C5}"/>
+                <a16:creationId xmlns:a16="http://schemas.microsoft.com/office/drawing/2014/main" id="{2CC2F6D8-6DF6-40D9-A728-042B9B7FC022}"/>
               </a:ext>
             </a:extLst>
           </p:cNvPr>
@@ -2550,7 +2590,7 @@
           <p:cNvPr id="3" name="Title">
             <a:extLst xmlns:a="http://schemas.openxmlformats.org/drawingml/2006/main">
               <a:ext uri="{FF2B5EF4-FFF2-40B4-BE49-F238E27FC236}">
-                <a16:creationId xmlns:a16="http://schemas.microsoft.com/office/drawing/2014/main" id="{48417767-C613-4CF1-B40C-207CFE9B62B1}"/>
+                <a16:creationId xmlns:a16="http://schemas.microsoft.com/office/drawing/2014/main" id="{3C971D23-B28F-4881-96BA-08CE614D78C1}"/>
               </a:ext>
             </a:extLst>
           </p:cNvPr>
@@ -2707,7 +2747,7 @@
           <p:cNvPr id="2" name="Left column">
             <a:extLst xmlns:a="http://schemas.openxmlformats.org/drawingml/2006/main">
               <a:ext uri="{FF2B5EF4-FFF2-40B4-BE49-F238E27FC236}">
-                <a16:creationId xmlns:a16="http://schemas.microsoft.com/office/drawing/2014/main" id="{B0695E0A-B263-4591-8F61-92FA8478A99C}"/>
+                <a16:creationId xmlns:a16="http://schemas.microsoft.com/office/drawing/2014/main" id="{D3390F1B-2115-4171-82FF-7D0718069385}"/>
               </a:ext>
             </a:extLst>
           </p:cNvPr>
@@ -2902,12 +2942,12 @@
   </p:cSld>
   <p:clrMap bg1="lt1" tx1="dk1" bg2="lt2" tx2="dk2" accent1="accent1" accent2="accent2" accent3="accent3" accent4="accent4" accent5="accent5" accent6="accent6" hlink="hlink" folHlink="folHlink"/>
   <p:sldLayoutIdLst>
-    <p:sldLayoutId xmlns:r="http://schemas.openxmlformats.org/officeDocument/2006/relationships" id="2147483649" r:id="R2e6f598ce2334dd6"/>
-    <p:sldLayoutId xmlns:r="http://schemas.openxmlformats.org/officeDocument/2006/relationships" id="2147483650" r:id="R5c2d3d5bfe6e41b9"/>
-    <p:sldLayoutId xmlns:r="http://schemas.openxmlformats.org/officeDocument/2006/relationships" id="2147483651" r:id="R62458ab5dae24488"/>
-    <p:sldLayoutId xmlns:r="http://schemas.openxmlformats.org/officeDocument/2006/relationships" id="2147483652" r:id="R4e9b821e2d254618"/>
-    <p:sldLayoutId xmlns:r="http://schemas.openxmlformats.org/officeDocument/2006/relationships" id="2147483653" r:id="R1e24352b62944454"/>
-    <p:sldLayoutId xmlns:r="http://schemas.openxmlformats.org/officeDocument/2006/relationships" id="2147483654" r:id="R8b8d31c783f44abe"/>
+    <p:sldLayoutId xmlns:r="http://schemas.openxmlformats.org/officeDocument/2006/relationships" id="2147483649" r:id="R50819a3613b44a5d"/>
+    <p:sldLayoutId xmlns:r="http://schemas.openxmlformats.org/officeDocument/2006/relationships" id="2147483650" r:id="Rb0921f92a67d4e91"/>
+    <p:sldLayoutId xmlns:r="http://schemas.openxmlformats.org/officeDocument/2006/relationships" id="2147483651" r:id="R594fc124047447e6"/>
+    <p:sldLayoutId xmlns:r="http://schemas.openxmlformats.org/officeDocument/2006/relationships" id="2147483652" r:id="R8447d0558d0e465e"/>
+    <p:sldLayoutId xmlns:r="http://schemas.openxmlformats.org/officeDocument/2006/relationships" id="2147483653" r:id="R777177624fd84774"/>
+    <p:sldLayoutId xmlns:r="http://schemas.openxmlformats.org/officeDocument/2006/relationships" id="2147483654" r:id="Ra834b94bcffc43b8"/>
   </p:sldLayoutIdLst>
   <p:txStyles>
     <p:titleStyle>
@@ -3458,7 +3498,7 @@
           <ns0:cNvPr id="5" name="Plan a badge-cost program">
             <ns1:extLst>
               <ns1:ext uri="{FF2B5EF4-FFF2-40B4-BE49-F238E27FC236}">
-                <ns2:creationId id="{F3343036-7CFC-4214-8179-57072091C7FA}"/>
+                <ns2:creationId id="{B5F6FD46-8A1C-48C1-ACE6-FA0CC1AD3B4A}"/>
               </ns1:ext>
             </ns1:extLst>
           </ns0:cNvPr>
@@ -3526,7 +3566,7 @@
           <ns0:cNvPr id="2" name="Unit 1 · Week 1 · Lesson 1">
             <ns1:extLst>
               <ns1:ext uri="{FF2B5EF4-FFF2-40B4-BE49-F238E27FC236}">
-                <ns2:creationId id="{5CB60018-BFD2-415F-8039-63CC27287664}"/>
+                <ns2:creationId id="{337C1C86-6B24-4084-9D5F-2979AA4AACB3}"/>
               </ns1:ext>
             </ns1:extLst>
           </ns0:cNvPr>
@@ -3592,7 +3632,7 @@
           <ns0:cNvPr id="3" name="Explain the problem before writing code.">
             <ns1:extLst>
               <ns1:ext uri="{FF2B5EF4-FFF2-40B4-BE49-F238E27FC236}">
-                <ns2:creationId id="{70CCF4D4-5E11-4E8A-ACD1-76ECC039ADE0}"/>
+                <ns2:creationId id="{59F8AB5D-EE6E-4B42-9592-E44D0AA70D72}"/>
               </ns1:ext>
             </ns1:extLst>
           </ns0:cNvPr>
@@ -3658,7 +3698,7 @@
           <ns0:cNvPr id="4" name="U1-W01-L01  ·  1/8  ·  Content CC BY 4.0 / code MIT">
             <ns1:extLst>
               <ns1:ext uri="{FF2B5EF4-FFF2-40B4-BE49-F238E27FC236}">
-                <ns2:creationId id="{28456FB0-5070-49CF-B2F0-63F4DDB819D1}"/>
+                <ns2:creationId id="{97360318-D529-4C55-8CA0-4B345D02BBEF}"/>
               </ns1:ext>
             </ns1:extLst>
           </ns0:cNvPr>
@@ -3722,7 +3762,7 @@
     </ns0:spTree>
     <ns0:extLst>
       <ns0:ext uri="{BB962C8B-B14F-4D97-AF65-F5344CB8AC3E}">
-        <ns3:creationId val="9742630"/>
+        <ns3:creationId val="1575961761"/>
       </ns0:ext>
     </ns0:extLst>
   </ns0:cSld>
@@ -3750,10 +3790,10 @@
       </ns0:grpSpPr>
       <ns0:sp>
         <ns0:nvSpPr>
-          <ns0:cNvPr id="6" name="What does a program need?">
+          <ns0:cNvPr id="7" name="What does a program need?">
             <ns1:extLst>
               <ns1:ext uri="{FF2B5EF4-FFF2-40B4-BE49-F238E27FC236}">
-                <ns2:creationId id="{6488E6CB-6302-4A76-B8DE-91E72F16DBDD}"/>
+                <ns2:creationId id="{F1823827-7438-4E58-AFF1-37640C579A0A}"/>
               </ns1:ext>
             </ns1:extLst>
           </ns0:cNvPr>
@@ -3821,7 +3861,7 @@
           <ns0:cNvPr id="2" name="A club sells badges for $3 each.">
             <ns1:extLst>
               <ns1:ext uri="{FF2B5EF4-FFF2-40B4-BE49-F238E27FC236}">
-                <ns2:creationId id="{3D0AF51E-DA04-47E8-B446-2F2A869F861B}"/>
+                <ns2:creationId id="{B387CBD5-6241-493B-8EB6-CF8863C73168}"/>
               </ns1:ext>
             </ns1:extLst>
           </ns0:cNvPr>
@@ -3884,10 +3924,10 @@
       </ns0:sp>
       <ns0:sp>
         <ns0:nvSpPr>
-          <ns0:cNvPr id="3" name="What must we know to calculate an order?">
+          <ns0:cNvPr id="3" name="Think alone: what input do we need?">
             <ns1:extLst>
               <ns1:ext uri="{FF2B5EF4-FFF2-40B4-BE49-F238E27FC236}">
-                <ns2:creationId id="{A9D1BBF0-47AD-4EC7-9FFC-895E98214164}"/>
+                <ns2:creationId id="{2D5FFE2F-0CB9-4B27-BA08-EB780715B4AB}"/>
               </ns1:ext>
             </ns1:extLst>
           </ns0:cNvPr>
@@ -3943,17 +3983,17 @@
                 <ns1:ea typeface="Arial"/>
                 <ns1:cs typeface="Arial"/>
               </ns1:rPr>
-              <ns1:t>What must we know to calculate an order?</ns1:t>
+              <ns1:t>Think alone: what input do we need?</ns1:t>
             </ns1:r>
           </ns1:p>
         </ns0:txBody>
       </ns0:sp>
       <ns0:sp>
         <ns0:nvSpPr>
-          <ns0:cNvPr id="4" name="How would you find the cost of four badges?">
+          <ns0:cNvPr id="4" name="Compare with a partner: what should four badges cost?">
             <ns1:extLst>
               <ns1:ext uri="{FF2B5EF4-FFF2-40B4-BE49-F238E27FC236}">
-                <ns2:creationId id="{5E2F4653-9492-4D68-9291-7E2B38E6D2B7}"/>
+                <ns2:creationId id="{266DB077-3BD8-41E8-899D-CB90018471A8}"/>
               </ns1:ext>
             </ns1:extLst>
           </ns0:cNvPr>
@@ -4009,17 +4049,83 @@
                 <ns1:ea typeface="Arial"/>
                 <ns1:cs typeface="Arial"/>
               </ns1:rPr>
-              <ns1:t>How would you find the cost of four badges?</ns1:t>
+              <ns1:t>Compare with a partner: what should four badges cost?</ns1:t>
             </ns1:r>
           </ns1:p>
         </ns0:txBody>
       </ns0:sp>
       <ns0:sp>
         <ns0:nvSpPr>
-          <ns0:cNvPr id="5" name="U1-W01-L01  ·  2/8  ·  Content CC BY 4.0 / code MIT">
+          <ns0:cNvPr id="5" name="Share your method, then try six badges.">
             <ns1:extLst>
               <ns1:ext uri="{FF2B5EF4-FFF2-40B4-BE49-F238E27FC236}">
-                <ns2:creationId id="{43E27C28-A309-4C8E-B21B-FB1DBF74F6FE}"/>
+                <ns2:creationId id="{34BB4749-D2CA-4B49-82E5-76C831F34A79}"/>
+              </ns1:ext>
+            </ns1:extLst>
+          </ns0:cNvPr>
+          <ns0:cNvSpPr>
+            <ns1:spLocks noGrp="1"/>
+          </ns0:cNvSpPr>
+          <ns0:nvPr/>
+        </ns0:nvSpPr>
+        <ns0:spPr>
+          <ns1:xfrm>
+            <ns1:off x="685800" y="4305300"/>
+            <ns1:ext cx="10820400" cy="714375"/>
+          </ns1:xfrm>
+          <ns1:prstGeom prst="rect">
+            <ns1:avLst/>
+          </ns1:prstGeom>
+          <ns1:noFill/>
+          <ns1:ln w="0">
+            <ns1:noFill/>
+          </ns1:ln>
+        </ns0:spPr>
+        <ns0:txBody>
+          <ns1:bodyPr/>
+          <ns1:lstStyle>
+            <ns1:defPPr>
+              <ns1:defRPr sz="2400" b="0">
+                <ns1:solidFill>
+                  <ns1:srgbClr val="18322D"/>
+                </ns1:solidFill>
+                <ns1:latin typeface="Arial"/>
+                <ns1:ea typeface="Arial"/>
+                <ns1:cs typeface="Arial"/>
+              </ns1:defRPr>
+            </ns1:defPPr>
+          </ns1:lstStyle>
+          <ns1:p>
+            <ns1:pPr>
+              <ns1:defRPr sz="2400" b="0">
+                <ns1:solidFill>
+                  <ns1:srgbClr val="18322D"/>
+                </ns1:solidFill>
+                <ns1:latin typeface="Arial"/>
+                <ns1:ea typeface="Arial"/>
+                <ns1:cs typeface="Arial"/>
+              </ns1:defRPr>
+            </ns1:pPr>
+            <ns1:r>
+              <ns1:rPr sz="2400" b="0">
+                <ns1:solidFill>
+                  <ns1:srgbClr val="18322D"/>
+                </ns1:solidFill>
+                <ns1:latin typeface="Arial"/>
+                <ns1:ea typeface="Arial"/>
+                <ns1:cs typeface="Arial"/>
+              </ns1:rPr>
+              <ns1:t>Share your method, then try six badges.</ns1:t>
+            </ns1:r>
+          </ns1:p>
+        </ns0:txBody>
+      </ns0:sp>
+      <ns0:sp>
+        <ns0:nvSpPr>
+          <ns0:cNvPr id="6" name="U1-W01-L01  ·  2/8  ·  Content CC BY 4.0 / code MIT">
+            <ns1:extLst>
+              <ns1:ext uri="{FF2B5EF4-FFF2-40B4-BE49-F238E27FC236}">
+                <ns2:creationId id="{A4139178-9DA2-4E14-9903-C8EE088D5CAF}"/>
               </ns1:ext>
             </ns1:extLst>
           </ns0:cNvPr>
@@ -4083,7 +4189,7 @@
     </ns0:spTree>
     <ns0:extLst>
       <ns0:ext uri="{BB962C8B-B14F-4D97-AF65-F5344CB8AC3E}">
-        <ns3:creationId val="1296500223"/>
+        <ns3:creationId val="367351884"/>
       </ns0:ext>
     </ns0:extLst>
   </ns0:cSld>
@@ -4114,7 +4220,7 @@
           <ns0:cNvPr id="6" name="Today’s goal">
             <ns1:extLst>
               <ns1:ext uri="{FF2B5EF4-FFF2-40B4-BE49-F238E27FC236}">
-                <ns2:creationId id="{89E43305-7855-4721-BF93-CBB1F0EEEA21}"/>
+                <ns2:creationId id="{C4BA89A6-744A-4397-B3CB-C31D6E10D392}"/>
               </ns1:ext>
             </ns1:extLst>
           </ns0:cNvPr>
@@ -4179,10 +4285,10 @@
       </ns0:sp>
       <ns0:sp>
         <ns0:nvSpPr>
-          <ns0:cNvPr id="2" name="Identify input, processing and output.">
+          <ns0:cNvPr id="2" name="I can identify input, processing and output.">
             <ns1:extLst>
               <ns1:ext uri="{FF2B5EF4-FFF2-40B4-BE49-F238E27FC236}">
-                <ns2:creationId id="{A9356BC9-1F03-4B3F-8BA8-814CD16067F5}"/>
+                <ns2:creationId id="{71D61C7A-781D-486D-95CB-B3DD3714085A}"/>
               </ns1:ext>
             </ns1:extLst>
           </ns0:cNvPr>
@@ -4238,17 +4344,17 @@
                 <ns1:ea typeface="Arial"/>
                 <ns1:cs typeface="Arial"/>
               </ns1:rPr>
-              <ns1:t>Identify input, processing and output.</ns1:t>
+              <ns1:t>I can identify input, processing and output.</ns1:t>
             </ns1:r>
           </ns1:p>
         </ns0:txBody>
       </ns0:sp>
       <ns0:sp>
         <ns0:nvSpPr>
-          <ns0:cNvPr id="3" name="Write ordered steps for a calculation.">
+          <ns0:cNvPr id="3" name="I can write calculation steps in order.">
             <ns1:extLst>
               <ns1:ext uri="{FF2B5EF4-FFF2-40B4-BE49-F238E27FC236}">
-                <ns2:creationId id="{88EF065D-B7E6-4DBA-BD06-20883C50611E}"/>
+                <ns2:creationId id="{28C8AF86-B490-406F-9838-56F22A701272}"/>
               </ns1:ext>
             </ns1:extLst>
           </ns0:cNvPr>
@@ -4304,17 +4410,17 @@
                 <ns1:ea typeface="Arial"/>
                 <ns1:cs typeface="Arial"/>
               </ns1:rPr>
-              <ns1:t>Write ordered steps for a calculation.</ns1:t>
+              <ns1:t>I can write calculation steps in order.</ns1:t>
             </ns1:r>
           </ns1:p>
         </ns0:txBody>
       </ns0:sp>
       <ns0:sp>
         <ns0:nvSpPr>
-          <ns0:cNvPr id="4" name="Calculate an expected result before testing.">
+          <ns0:cNvPr id="4" name="I can predict a result before testing.">
             <ns1:extLst>
               <ns1:ext uri="{FF2B5EF4-FFF2-40B4-BE49-F238E27FC236}">
-                <ns2:creationId id="{A8003E34-9DF9-446A-8C2D-3E9A803F1100}"/>
+                <ns2:creationId id="{33F646F2-9A2A-408A-ADDD-B8EC56F44767}"/>
               </ns1:ext>
             </ns1:extLst>
           </ns0:cNvPr>
@@ -4370,7 +4476,7 @@
                 <ns1:ea typeface="Arial"/>
                 <ns1:cs typeface="Arial"/>
               </ns1:rPr>
-              <ns1:t>Calculate an expected result before testing.</ns1:t>
+              <ns1:t>I can predict a result before testing.</ns1:t>
             </ns1:r>
           </ns1:p>
         </ns0:txBody>
@@ -4380,7 +4486,7 @@
           <ns0:cNvPr id="5" name="U1-W01-L01  ·  3/8  ·  Content CC BY 4.0 / code MIT">
             <ns1:extLst>
               <ns1:ext uri="{FF2B5EF4-FFF2-40B4-BE49-F238E27FC236}">
-                <ns2:creationId id="{6FBA77BC-46E7-4942-8162-5A1BFC963A10}"/>
+                <ns2:creationId id="{44D19451-1305-4F93-8592-366A7399779C}"/>
               </ns1:ext>
             </ns1:extLst>
           </ns0:cNvPr>
@@ -4444,7 +4550,7 @@
     </ns0:spTree>
     <ns0:extLst>
       <ns0:ext uri="{BB962C8B-B14F-4D97-AF65-F5344CB8AC3E}">
-        <ns3:creationId val="1463166517"/>
+        <ns3:creationId val="826924018"/>
       </ns0:ext>
     </ns0:extLst>
   </ns0:cSld>
@@ -4475,7 +4581,7 @@
           <ns0:cNvPr id="7" name="The badge requirement">
             <ns1:extLst>
               <ns1:ext uri="{FF2B5EF4-FFF2-40B4-BE49-F238E27FC236}">
-                <ns2:creationId id="{47F2980C-A354-48CF-B67B-723357973DAB}"/>
+                <ns2:creationId id="{AC03EBA6-A93D-46A6-9FFA-F6768C57821A}"/>
               </ns1:ext>
             </ns1:extLst>
           </ns0:cNvPr>
@@ -4543,7 +4649,7 @@
           <ns0:cNvPr id="2" name="Display the cost for a valid badge quantity.">
             <ns1:extLst>
               <ns1:ext uri="{FF2B5EF4-FFF2-40B4-BE49-F238E27FC236}">
-                <ns2:creationId id="{B251AA19-7365-4A0E-B373-46C4322BD3E7}"/>
+                <ns2:creationId id="{40C10C3D-66FA-4E58-8082-55A35DBA57E9}"/>
               </ns1:ext>
             </ns1:extLst>
           </ns0:cNvPr>
@@ -4609,7 +4715,7 @@
           <ns0:cNvPr id="3" name="Each badge costs $3.">
             <ns1:extLst>
               <ns1:ext uri="{FF2B5EF4-FFF2-40B4-BE49-F238E27FC236}">
-                <ns2:creationId id="{8E7EBD28-0617-4D7D-AE1B-4D1D6CD0091A}"/>
+                <ns2:creationId id="{1BF1A7BB-3886-42BA-ACA5-001BA2DF5672}"/>
               </ns1:ext>
             </ns1:extLst>
           </ns0:cNvPr>
@@ -4675,7 +4781,7 @@
           <ns0:cNvPr id="4" name="Assume a whole-number quantity of zero or more.">
             <ns1:extLst>
               <ns1:ext uri="{FF2B5EF4-FFF2-40B4-BE49-F238E27FC236}">
-                <ns2:creationId id="{75982B80-5265-4BFF-BE57-DCBF659CCF86}"/>
+                <ns2:creationId id="{D17C3297-A912-4F9D-8278-D111ABDBE15A}"/>
               </ns1:ext>
             </ns1:extLst>
           </ns0:cNvPr>
@@ -4741,7 +4847,7 @@
           <ns0:cNvPr id="5" name="Input validation is taught later.">
             <ns1:extLst>
               <ns1:ext uri="{FF2B5EF4-FFF2-40B4-BE49-F238E27FC236}">
-                <ns2:creationId id="{24C3B593-BA66-498D-8BD5-F7BD226E7D0C}"/>
+                <ns2:creationId id="{AA16368C-78CB-4F4D-B362-71F7F8B8C490}"/>
               </ns1:ext>
             </ns1:extLst>
           </ns0:cNvPr>
@@ -4807,7 +4913,7 @@
           <ns0:cNvPr id="6" name="U1-W01-L01  ·  4/8  ·  Content CC BY 4.0 / code MIT">
             <ns1:extLst>
               <ns1:ext uri="{FF2B5EF4-FFF2-40B4-BE49-F238E27FC236}">
-                <ns2:creationId id="{340002D8-29CB-4046-84E6-19C404556636}"/>
+                <ns2:creationId id="{FD6AE95B-1B4E-4AAE-A840-530D87D7382C}"/>
               </ns1:ext>
             </ns1:extLst>
           </ns0:cNvPr>
@@ -4871,7 +4977,7 @@
     </ns0:spTree>
     <ns0:extLst>
       <ns0:ext uri="{BB962C8B-B14F-4D97-AF65-F5344CB8AC3E}">
-        <ns3:creationId val="146160421"/>
+        <ns3:creationId val="308764781"/>
       </ns0:ext>
     </ns0:extLst>
   </ns0:cSld>
@@ -4899,10 +5005,10 @@
       </ns0:grpSpPr>
       <ns0:sp>
         <ns0:nvSpPr>
-          <ns0:cNvPr id="4" name="Input, processing and output">
+          <ns0:cNvPr id="4" name="A worked example: four badges">
             <ns1:extLst>
               <ns1:ext uri="{FF2B5EF4-FFF2-40B4-BE49-F238E27FC236}">
-                <ns2:creationId id="{BAE75BA4-3442-4919-829E-806462E89B0A}"/>
+                <ns2:creationId id="{4CBAAEB8-1D67-4CF8-9AE7-02A615BF14A0}"/>
               </ns1:ext>
             </ns1:extLst>
           </ns0:cNvPr>
@@ -4960,7 +5066,7 @@
                 <ns1:ea typeface="Arial"/>
                 <ns1:cs typeface="Arial"/>
               </ns1:rPr>
-              <ns1:t>Input, processing and output</ns1:t>
+              <ns1:t>A worked example: four badges</ns1:t>
             </ns1:r>
           </ns1:p>
         </ns0:txBody>
@@ -4970,7 +5076,7 @@
           <ns0:cNvPr id="2" name="">
             <ns1:extLst>
               <ns1:ext uri="{FF2B5EF4-FFF2-40B4-BE49-F238E27FC236}">
-                <ns2:creationId id="{D6849835-E6F5-4CD6-A93E-BC6BD4869BB8}"/>
+                <ns2:creationId id="{9ABB30E3-51E7-4BF3-971A-D2CAE7D940DE}"/>
               </ns1:ext>
             </ns1:extLst>
           </ns0:cNvPr>
@@ -5330,7 +5436,7 @@
           <ns0:cNvPr id="3" name="U1-W01-L01  ·  5/8  ·  Content CC BY 4.0 / code MIT">
             <ns1:extLst>
               <ns1:ext uri="{FF2B5EF4-FFF2-40B4-BE49-F238E27FC236}">
-                <ns2:creationId id="{5A8335C3-4682-4470-87A3-E0FA418265B8}"/>
+                <ns2:creationId id="{580E9962-24CF-4AAE-A227-A513E0181801}"/>
               </ns1:ext>
             </ns1:extLst>
           </ns0:cNvPr>
@@ -5394,7 +5500,7 @@
     </ns0:spTree>
     <ns0:extLst>
       <ns0:ext uri="{BB962C8B-B14F-4D97-AF65-F5344CB8AC3E}">
-        <ns3:creationId val="553580798"/>
+        <ns3:creationId val="1927731106"/>
       </ns0:ext>
     </ns0:extLst>
   </ns0:cSld>
@@ -5422,10 +5528,10 @@
       </ns0:grpSpPr>
       <ns0:sp>
         <ns0:nvSpPr>
-          <ns0:cNvPr id="7" name="Write an algorithm">
+          <ns0:cNvPr id="7" name="An algorithm for any quantity">
             <ns1:extLst>
               <ns1:ext uri="{FF2B5EF4-FFF2-40B4-BE49-F238E27FC236}">
-                <ns2:creationId id="{BAFFE840-D511-473D-BA6D-0B7498668947}"/>
+                <ns2:creationId id="{3CD25F63-032B-4466-AEAC-774C5D25590A}"/>
               </ns1:ext>
             </ns1:extLst>
           </ns0:cNvPr>
@@ -5483,17 +5589,17 @@
                 <ns1:ea typeface="Arial"/>
                 <ns1:cs typeface="Arial"/>
               </ns1:rPr>
-              <ns1:t>Write an algorithm</ns1:t>
+              <ns1:t>An algorithm for any quantity</ns1:t>
             </ns1:r>
           </ns1:p>
         </ns0:txBody>
       </ns0:sp>
       <ns0:sp>
         <ns0:nvSpPr>
-          <ns0:cNvPr id="2" name="1. Read the badge quantity.">
+          <ns0:cNvPr id="2" name="Write the steps without looking at the example.">
             <ns1:extLst>
               <ns1:ext uri="{FF2B5EF4-FFF2-40B4-BE49-F238E27FC236}">
-                <ns2:creationId id="{EAFA4861-89ED-4C2F-9AB1-1A3BA2F90583}"/>
+                <ns2:creationId id="{22DE320D-8EFC-4467-A82E-BFAE7EEBBC3F}"/>
               </ns1:ext>
             </ns1:extLst>
           </ns0:cNvPr>
@@ -5549,17 +5655,17 @@
                 <ns1:ea typeface="Arial"/>
                 <ns1:cs typeface="Arial"/>
               </ns1:rPr>
-              <ns1:t>1. Read the badge quantity.</ns1:t>
+              <ns1:t>Write the steps without looking at the example.</ns1:t>
             </ns1:r>
           </ns1:p>
         </ns0:txBody>
       </ns0:sp>
       <ns0:sp>
         <ns0:nvSpPr>
-          <ns0:cNvPr id="3" name="2. Multiply the quantity by 3.">
+          <ns0:cNvPr id="3" name="Trace your steps for 0, 1 and 6 badges.">
             <ns1:extLst>
               <ns1:ext uri="{FF2B5EF4-FFF2-40B4-BE49-F238E27FC236}">
-                <ns2:creationId id="{8E518B25-80FF-4629-8FA9-7D887E09557C}"/>
+                <ns2:creationId id="{69CB6309-0330-431C-B43A-2674B02CCA68}"/>
               </ns1:ext>
             </ns1:extLst>
           </ns0:cNvPr>
@@ -5615,17 +5721,17 @@
                 <ns1:ea typeface="Arial"/>
                 <ns1:cs typeface="Arial"/>
               </ns1:rPr>
-              <ns1:t>2. Multiply the quantity by 3.</ns1:t>
+              <ns1:t>Trace your steps for 0, 1 and 6 badges.</ns1:t>
             </ns1:r>
           </ns1:p>
         </ns0:txBody>
       </ns0:sp>
       <ns0:sp>
         <ns0:nvSpPr>
-          <ns0:cNvPr id="4" name="3. Display the total.">
+          <ns0:cNvPr id="4" name="Explain your sequence to a partner.">
             <ns1:extLst>
               <ns1:ext uri="{FF2B5EF4-FFF2-40B4-BE49-F238E27FC236}">
-                <ns2:creationId id="{E15B4CBC-9070-40D5-A145-F79C772D6487}"/>
+                <ns2:creationId id="{47C086F9-A6E9-49ED-89C6-A041A95351D4}"/>
               </ns1:ext>
             </ns1:extLst>
           </ns0:cNvPr>
@@ -5681,17 +5787,17 @@
                 <ns1:ea typeface="Arial"/>
                 <ns1:cs typeface="Arial"/>
               </ns1:rPr>
-              <ns1:t>3. Display the total.</ns1:t>
+              <ns1:t>Explain your sequence to a partner.</ns1:t>
             </ns1:r>
           </ns1:p>
         </ns0:txBody>
       </ns0:sp>
       <ns0:sp>
         <ns0:nvSpPr>
-          <ns0:cNvPr id="5" name="Now trace the steps for 0, 1 and 6 badges.">
+          <ns0:cNvPr id="5" name="Revise any step your partner cannot follow.">
             <ns1:extLst>
               <ns1:ext uri="{FF2B5EF4-FFF2-40B4-BE49-F238E27FC236}">
-                <ns2:creationId id="{C499AFAA-EDF0-4C9F-8C01-B193F2E16A0F}"/>
+                <ns2:creationId id="{9BF058BB-8F68-4578-9A0D-1CEA24AA72DD}"/>
               </ns1:ext>
             </ns1:extLst>
           </ns0:cNvPr>
@@ -5747,7 +5853,7 @@
                 <ns1:ea typeface="Arial"/>
                 <ns1:cs typeface="Arial"/>
               </ns1:rPr>
-              <ns1:t>Now trace the steps for 0, 1 and 6 badges.</ns1:t>
+              <ns1:t>Revise any step your partner cannot follow.</ns1:t>
             </ns1:r>
           </ns1:p>
         </ns0:txBody>
@@ -5757,7 +5863,7 @@
           <ns0:cNvPr id="6" name="U1-W01-L01  ·  6/8  ·  Content CC BY 4.0 / code MIT">
             <ns1:extLst>
               <ns1:ext uri="{FF2B5EF4-FFF2-40B4-BE49-F238E27FC236}">
-                <ns2:creationId id="{5ADDBAD1-979F-47B3-B5AB-343C951C9571}"/>
+                <ns2:creationId id="{FF91E3D1-DB2B-4F8E-880B-7358346E4E55}"/>
               </ns1:ext>
             </ns1:extLst>
           </ns0:cNvPr>
@@ -5821,7 +5927,7 @@
     </ns0:spTree>
     <ns0:extLst>
       <ns0:ext uri="{BB962C8B-B14F-4D97-AF65-F5344CB8AC3E}">
-        <ns3:creationId val="807962928"/>
+        <ns3:creationId val="259519967"/>
       </ns0:ext>
     </ns0:extLst>
   </ns0:cSld>
@@ -5849,10 +5955,10 @@
       </ns0:grpSpPr>
       <ns0:sp>
         <ns0:nvSpPr>
-          <ns0:cNvPr id="7" name="Check the plan">
+          <ns0:cNvPr id="7" name="Which rule matches the requirement?">
             <ns1:extLst>
               <ns1:ext uri="{FF2B5EF4-FFF2-40B4-BE49-F238E27FC236}">
-                <ns2:creationId id="{92099386-1DC8-43AE-8E54-B7F9A4CF4FA3}"/>
+                <ns2:creationId id="{E4AA5967-5797-4F97-A6BA-8ED0F5B96191}"/>
               </ns1:ext>
             </ns1:extLst>
           </ns0:cNvPr>
@@ -5910,17 +6016,17 @@
                 <ns1:ea typeface="Arial"/>
                 <ns1:cs typeface="Arial"/>
               </ns1:rPr>
-              <ns1:t>Check the plan</ns1:t>
+              <ns1:t>Which rule matches the requirement?</ns1:t>
             </ns1:r>
           </ns1:p>
         </ns0:txBody>
       </ns0:sp>
       <ns0:sp>
         <ns0:nvSpPr>
-          <ns0:cNvPr id="2" name="Does it accept the required input?">
+          <ns0:cNvPr id="2" name="For six badges, choose a rule on paper.">
             <ns1:extLst>
               <ns1:ext uri="{FF2B5EF4-FFF2-40B4-BE49-F238E27FC236}">
-                <ns2:creationId id="{77FB4946-AC17-4C8D-A8F7-C2306ED7D980}"/>
+                <ns2:creationId id="{93E03971-584D-4B67-8375-0739FEC78A46}"/>
               </ns1:ext>
             </ns1:extLst>
           </ns0:cNvPr>
@@ -5976,17 +6082,17 @@
                 <ns1:ea typeface="Arial"/>
                 <ns1:cs typeface="Arial"/>
               </ns1:rPr>
-              <ns1:t>Does it accept the required input?</ns1:t>
+              <ns1:t>For six badges, choose a rule on paper.</ns1:t>
             </ns1:r>
           </ns1:p>
         </ns0:txBody>
       </ns0:sp>
       <ns0:sp>
         <ns0:nvSpPr>
-          <ns0:cNvPr id="3" name="Does it calculate the right result?">
+          <ns0:cNvPr id="3" name="A: quantity + 3     B: quantity × 3">
             <ns1:extLst>
               <ns1:ext uri="{FF2B5EF4-FFF2-40B4-BE49-F238E27FC236}">
-                <ns2:creationId id="{F5CB31AA-1203-430C-A82A-821D464480F6}"/>
+                <ns2:creationId id="{1A1DC1ED-60B6-436D-B641-7A46C66AD30B}"/>
               </ns1:ext>
             </ns1:extLst>
           </ns0:cNvPr>
@@ -6042,17 +6148,17 @@
                 <ns1:ea typeface="Arial"/>
                 <ns1:cs typeface="Arial"/>
               </ns1:rPr>
-              <ns1:t>Does it calculate the right result?</ns1:t>
+              <ns1:t>A: quantity + 3     B: quantity × 3</ns1:t>
             </ns1:r>
           </ns1:p>
         </ns0:txBody>
       </ns0:sp>
       <ns0:sp>
         <ns0:nvSpPr>
-          <ns0:cNvPr id="4" name="Does it display that result?">
+          <ns0:cNvPr id="4" name="Show your choice together.">
             <ns1:extLst>
               <ns1:ext uri="{FF2B5EF4-FFF2-40B4-BE49-F238E27FC236}">
-                <ns2:creationId id="{FEAB1DF0-C505-4621-ABBB-F6D944FC92C0}"/>
+                <ns2:creationId id="{4173A0FF-2531-4C00-B651-30B5FDB2C4A7}"/>
               </ns1:ext>
             </ns1:extLst>
           </ns0:cNvPr>
@@ -6108,17 +6214,17 @@
                 <ns1:ea typeface="Arial"/>
                 <ns1:cs typeface="Arial"/>
               </ns1:rPr>
-              <ns1:t>Does it display that result?</ns1:t>
+              <ns1:t>Show your choice together.</ns1:t>
             </ns1:r>
           </ns1:p>
         </ns0:txBody>
       </ns0:sp>
       <ns0:sp>
         <ns0:nvSpPr>
-          <ns0:cNvPr id="5" name="Compare with an independently calculated expectation.">
+          <ns0:cNvPr id="5" name="Explain what the other rule gets wrong.">
             <ns1:extLst>
               <ns1:ext uri="{FF2B5EF4-FFF2-40B4-BE49-F238E27FC236}">
-                <ns2:creationId id="{F777F30F-8AD8-4D01-B4B5-963207D3F943}"/>
+                <ns2:creationId id="{AFA0A178-A7CF-4A69-8C92-06C6E2DCCAEC}"/>
               </ns1:ext>
             </ns1:extLst>
           </ns0:cNvPr>
@@ -6174,7 +6280,7 @@
                 <ns1:ea typeface="Arial"/>
                 <ns1:cs typeface="Arial"/>
               </ns1:rPr>
-              <ns1:t>Compare with an independently calculated expectation.</ns1:t>
+              <ns1:t>Explain what the other rule gets wrong.</ns1:t>
             </ns1:r>
           </ns1:p>
         </ns0:txBody>
@@ -6184,7 +6290,7 @@
           <ns0:cNvPr id="6" name="U1-W01-L01  ·  7/8  ·  Content CC BY 4.0 / code MIT">
             <ns1:extLst>
               <ns1:ext uri="{FF2B5EF4-FFF2-40B4-BE49-F238E27FC236}">
-                <ns2:creationId id="{DA5E80E8-0137-49C6-BD1C-7986272EA320}"/>
+                <ns2:creationId id="{AC918A9B-BCA9-43B7-AFF3-C53E40460333}"/>
               </ns1:ext>
             </ns1:extLst>
           </ns0:cNvPr>
@@ -6248,7 +6354,7 @@
     </ns0:spTree>
     <ns0:extLst>
       <ns0:ext uri="{BB962C8B-B14F-4D97-AF65-F5344CB8AC3E}">
-        <ns3:creationId val="59889190"/>
+        <ns3:creationId val="1868685349"/>
       </ns0:ext>
     </ns0:extLst>
   </ns0:cSld>
@@ -6279,7 +6385,7 @@
           <ns0:cNvPr id="7" name="Exit check: seven badges">
             <ns1:extLst>
               <ns1:ext uri="{FF2B5EF4-FFF2-40B4-BE49-F238E27FC236}">
-                <ns2:creationId id="{10226837-CA77-452D-95DA-69DA7B361DE6}"/>
+                <ns2:creationId id="{5ED0CD17-9870-4AE5-A8C3-88286C284DFE}"/>
               </ns1:ext>
             </ns1:extLst>
           </ns0:cNvPr>
@@ -6347,7 +6453,7 @@
           <ns0:cNvPr id="2" name="Name the input.">
             <ns1:extLst>
               <ns1:ext uri="{FF2B5EF4-FFF2-40B4-BE49-F238E27FC236}">
-                <ns2:creationId id="{94D5278D-79A7-44B6-A8D7-9BC3BBD929D0}"/>
+                <ns2:creationId id="{4690B3D7-9BCA-45B3-9CF0-47CC6D2A5E65}"/>
               </ns1:ext>
             </ns1:extLst>
           </ns0:cNvPr>
@@ -6413,7 +6519,7 @@
           <ns0:cNvPr id="3" name="State the processing step.">
             <ns1:extLst>
               <ns1:ext uri="{FF2B5EF4-FFF2-40B4-BE49-F238E27FC236}">
-                <ns2:creationId id="{9818BCAA-F331-4BD9-B0A5-947950AF77CF}"/>
+                <ns2:creationId id="{1F054BA9-5D43-4DDC-8BB5-D48202A8D1AD}"/>
               </ns1:ext>
             </ns1:extLst>
           </ns0:cNvPr>
@@ -6479,7 +6585,7 @@
           <ns0:cNvPr id="4" name="Give the expected displayed total.">
             <ns1:extLst>
               <ns1:ext uri="{FF2B5EF4-FFF2-40B4-BE49-F238E27FC236}">
-                <ns2:creationId id="{CC9C6994-A9FE-46A0-A1E7-D10FED8A7D4D}"/>
+                <ns2:creationId id="{60D07D65-02B0-44B8-957C-891ABF7AFAC2}"/>
               </ns1:ext>
             </ns1:extLst>
           </ns0:cNvPr>
@@ -6545,7 +6651,7 @@
           <ns0:cNvPr id="5" name="Explain why an expected result is useful.">
             <ns1:extLst>
               <ns1:ext uri="{FF2B5EF4-FFF2-40B4-BE49-F238E27FC236}">
-                <ns2:creationId id="{CE84BAAC-D318-4496-938D-B183540ADE9B}"/>
+                <ns2:creationId id="{768FA4A6-8C74-45F2-AA24-71D168C11141}"/>
               </ns1:ext>
             </ns1:extLst>
           </ns0:cNvPr>
@@ -6611,7 +6717,7 @@
           <ns0:cNvPr id="6" name="U1-W01-L01  ·  8/8  ·  Content CC BY 4.0 / code MIT">
             <ns1:extLst>
               <ns1:ext uri="{FF2B5EF4-FFF2-40B4-BE49-F238E27FC236}">
-                <ns2:creationId id="{3436F603-0B71-4B90-BCFB-265971522F1B}"/>
+                <ns2:creationId id="{48A19F1E-0752-4F21-9C92-AA195E2C439D}"/>
               </ns1:ext>
             </ns1:extLst>
           </ns0:cNvPr>
@@ -6675,7 +6781,7 @@
     </ns0:spTree>
     <ns0:extLst>
       <ns0:ext uri="{BB962C8B-B14F-4D97-AF65-F5344CB8AC3E}">
-        <ns3:creationId val="1375371203"/>
+        <ns3:creationId val="544607616"/>
       </ns0:ext>
     </ns0:extLst>
   </ns0:cSld>

</xml_diff>